<commit_message>
docs: expand presentation slides and speaker notes to 12 minutes
</commit_message>
<xml_diff>
--- a/MeetPoint_Praesentation.pptx
+++ b/MeetPoint_Praesentation.pptx
@@ -507,7 +507,19 @@
           <a:lstStyle/>
           <a:p>
             <a:r>
-              <a:t>Herzlich willkommen zu unserer Abschlusspräsentation für das Modul 306. Wir präsentieren euch heute unser Projekt 'MeetPoint'. Jeder von euch kennt es wahrscheinlich: Man will etwas mit Freunden unternehmen, aber die Terminfindung in WhatsApp-Gruppen endet im totalen Chaos. Genau dieses Problem haben wir gelöst.</a:t>
+              <a:t>Guten Tag zusammen und herzlich willkommen zu unserer Abschlusspräsentation für das Modul 306. Wir freuen uns sehr, Ihnen heute unser Abschlussprojekt 'MeetPoint' vorstellen zu dürfen.</a:t>
+            </a:r>
+          </a:p>
+          <a:p/>
+          <a:p>
+            <a:r>
+              <a:t>Jeder von uns kennt dieses Problem aus dem Alltag: Man möchte sich mit Freunden treffen, einen gemeinsamen Grillabend organisieren, Sport treiben oder die Sommerferien planen. Die Absprache in klassischen Messengern wie WhatsApp endet jedoch meist in einer endlosen Flut von Nachrichten. Details gehen verloren, Terminvorschläge werden überschrieben und am Ende weiss niemand mehr genau, wer zugesagt hat und worauf man sich geeinigt hat.</a:t>
+            </a:r>
+          </a:p>
+          <a:p/>
+          <a:p>
+            <a:r>
+              <a:t>Genau hier setzt MeetPoint an. Wir haben eine Web-Applikation entwickelt, die dieses 'Chat-Chaos' beseitigt. In den nächsten 12 Minuten möchten wir Ihnen unsere Ausgangslage, die Anforderungen, unsere technische Architektur sowie die grössten Herausforderungen vorstellen. Das Herzstück der Präsentation bildet eine anschliessende Live-Demo, in der wir Ihnen die voll funktionsfähige App zeigen.</a:t>
             </a:r>
           </a:p>
         </p:txBody>
@@ -577,13 +589,19 @@
           <a:lstStyle/>
           <a:p>
             <a:r>
-              <a:t>Die Ausgangslage für unser Projekt war klar: Die Planung von Gruppenaktivitäten in klassischen Messengern ist mühsam. Wer hat wann Zeit? Worauf haben die Leute überhaupt Lust? Das geht alles im Chat-Verlauf unter.</a:t>
+              <a:t>Beginnen wir mit der Projektübersicht und unserer Motivation für MeetPoint.</a:t>
             </a:r>
           </a:p>
           <a:p/>
           <a:p>
             <a:r>
-              <a:t>Unser Projektziel war es daher, eine spezialisierte Web-App zu entwickeln. MeetPoint strukturiert den gesamten Ablauf: Von der Themengruppe, über das Sammeln von Interessen und Aktivitäten, bis hin zur finalen Terminabstimmung.</a:t>
+              <a:t>Die klassische Terminfindung in Freundesgruppen ist extrem ineffizient. Natürlich existieren bereits Hilfsmittel. Doch wenn man WhatsApp-Umfragen nutzt, verschwinden diese im Verlauf und man muss mühsam hochscrollen. Verwendet man Doodle, stört die massive Werbung, und die Plattform ist für wiederkehrende Freundesgruppen viel zu unpersönlich und bietet keine Möglichkeit, Gruppen dauerhaft zu speichern.</a:t>
+            </a:r>
+          </a:p>
+          <a:p/>
+          <a:p>
+            <a:r>
+              <a:t>Unser Projektziel war es daher, eine spezialisierte Komplettlösung zu schaffen. In MeetPoint ist jede Gruppe ein fester Workspace. Mitglieder können ihre Interessen angeben, damit die Gruppe sofort sieht, welche Aktivitäten überhaupt Sinn machen. Das Kern-Feature ist unser Abstimmungssystem: Sobald eine Aktivität erstellt wird, können mehrere Termine vorgeschlagen werden. Die Gruppenmitglieder stimmen ab, und das System berechnet live und dynamisch, welcher Termin die maximale Zustimmung hat. Das verkürzt die Planung von Tagen auf wenige Sekunden und schafft absolute Klarheit für alle Beteiligten.</a:t>
             </a:r>
           </a:p>
         </p:txBody>
@@ -653,19 +671,19 @@
           <a:lstStyle/>
           <a:p>
             <a:r>
-              <a:t>In der Analyse haben wir die wichtigsten Anforderungen definiert: Wir brauchten ein System für Gruppen, Aktivitäten und eine Abstimmungslogik, die am Ende automatisch einen Gewinner-Termin ermittelt.</a:t>
+              <a:t>Für die technische Umsetzung haben wir uns im Vorfeld intensiv mit der Architektur und den Anforderungen auseinandergesetzt.</a:t>
             </a:r>
           </a:p>
           <a:p/>
           <a:p>
             <a:r>
-              <a:t>Wir haben uns für Vue 3 im Frontend entschieden, da es schnelle, reaktive Benutzeroberflächen ermöglicht. Für das Design haben wir bewusst auf ein modernes Dark-Theme mit Glassmorphism gesetzt, um den Nutzern ein Premium-Gefühl zu geben.</a:t>
+              <a:t>Bei den funktionalen Anforderungen war uns wichtig, dass die App absolut dynamisch wirkt. Wenn ein Benutzer seine Stimme abgibt, darf die Seite nicht neu laden müssen – der Daumen-Zähler und der Gewinner-Termin müssen sich sofort aktualisieren. Ausserdem wollten wir ein premium-ähnliches Design, weshalb wir uns für ein modernes Dark-Theme mit transparenten 'Glassmorphism'-Elementen entschieden haben.</a:t>
             </a:r>
           </a:p>
           <a:p/>
           <a:p>
             <a:r>
-              <a:t>Im Backend setzen wir auf PostgreSQL in Kombination mit PostgREST über Docker. Die Begründung: PostgREST generiert uns automatisch und fehlerfrei eine REST-API aus unserem Datenbankschema, was uns enorm viel Entwicklungszeit gespart hat.</a:t>
+              <a:t>In der Architektur haben wir eine klare Trennung vollzogen. Im Frontend nutzen wir Vue 3 mit TypeScript. Vue bietet uns eine reaktive Datenbindung und eine saubere Strukturierung in wiederverwendbare UI-Komponenten. Im Backend setzen wir auf eine PostgreSQL-Datenbank. Um nicht wochenlang ein eigenes Backend-API-Projekt in Node.js oder C# schreiben zu müssen, haben wir PostgREST gewählt. PostgREST läuft in einem Docker-Container und stellt uns automatisch eine REST-API auf Basis unserer Datenbanktabellen zur Verfügung. Jede Tabellenänderung spiegelt sich sofort in der API wider. Das hat uns enorm viel Entwicklungszeit gespart, die wir stattdessen in die Verfeinerung des Frontends investieren konnten.</a:t>
             </a:r>
           </a:p>
         </p:txBody>
@@ -735,13 +753,19 @@
           <a:lstStyle/>
           <a:p>
             <a:r>
-              <a:t>Die grösste Herausforderung in der Entwicklung war das Berechtigungskonzept und die Datensicherheit. Da unser MVP aktuell noch ohne komplexe JWT-Authentifizierung läuft, bestand das Risiko, dass jeder Nutzer über die API theoretisch alles löschen könnte.</a:t>
+              <a:t>Die grösste technische Herausforderung bei diesem Projekt war das Sicherheits- und Berechtigungskonzept.</a:t>
             </a:r>
           </a:p>
           <a:p/>
           <a:p>
             <a:r>
-              <a:t>Um dieses kritische Risiko zu beheben, haben wir tiefe Datenbank-Massnahmen getroffen: Wir haben der API die generellen Löschrechte entzogen und stattdessen sichere RPC-Funktionen in PostgreSQL geschrieben. Die Datenbank prüft nun bei jedem Klick knallhart selbst, ob die Person wirklich der Ersteller oder der Gruppenbesitzer ist. Erst dann wird etwas gelöscht.</a:t>
+              <a:t>Da wir für das gesamte Projekt nur wenig Zeit hatten, konnten wir kein vollwertiges JWT-Token-System integrieren. Das führte zu einem grossen Risiko: Die automatisch generierte API von PostgREST erlaubt standardmässig jedem, der die URL kennt, Daten abzufragen und zu löschen. Ein böswilliger Nutzer hätte also über Tools wie Postman fremde Gruppen, Interessen oder Termine löschen können.</a:t>
+            </a:r>
+          </a:p>
+          <a:p/>
+          <a:p>
+            <a:r>
+              <a:t>Um diese kritische Sicherheitslücke zu schliessen, haben wir das Problem direkt in der Datenbank gelöst. Wir haben der API jegliche direkten Löschrechte auf den Tabellen entzogen. Stattdessen haben wir serverseitige PostgreSQL-Funktionen (sogenannte Remote Procedure Calls oder Stored Procedures) geschrieben. Wenn ein Nutzer nun im Frontend auf 'Löschen' klickt, ruft er diese DB-Funktion auf. Die Funktion prüft intern in der Datenbank, ob die ID des Nutzers mit dem Ersteller des Eintrags oder dem Besitzer der Gruppe übereinstimmt. Nur wenn diese Prüfung erfolgreich ist, wird der Löschvorgang ausgeführt. Damit ist das Löschen absolut manipulationssicher – selbst wenn jemand versucht, die API direkt anzusprechen. Das garantiert die Datenintegrität auf Serverebene.</a:t>
             </a:r>
           </a:p>
         </p:txBody>
@@ -811,43 +835,43 @@
           <a:lstStyle/>
           <a:p>
             <a:r>
-              <a:t>Nun möchten wir euch MeetPoint live zeigen...</a:t>
+              <a:t>Nun kommen wir zum Kernstück unserer Präsentation: der Live-Demo. Wir möchten Ihnen zeigen, dass die Theorie auch in der Praxis einwandfrei funktioniert.</a:t>
             </a:r>
           </a:p>
           <a:p/>
           <a:p>
             <a:r>
-              <a:t>1. Start: Zeigt die schöne Login-/Registrierungsseite. Loggt euch mit einem vorbereiteten Account ein.</a:t>
-            </a:r>
-          </a:p>
-          <a:p>
-            <a:r>
-              <a:t>2. Dashboard &amp; Gruppe: Erklärt kurz den Planungs-Ablauf (Sidebar links). Erstellt live eine neue Gruppe (z.B. 'Sommerferien-Crew').</a:t>
-            </a:r>
-          </a:p>
-          <a:p>
-            <a:r>
-              <a:t>3. Interessen: Fügt 2-3 Interessen hinzu (z.B. 'Sport', 'Essen'). Zeigt, wie schnell das geht.</a:t>
-            </a:r>
-          </a:p>
-          <a:p>
-            <a:r>
-              <a:t>4. Aktivität erstellen: Klickt auf 'Neu' bei Aktivitäten (z.B. 'Grillabend'). Wählt dabei direkt die Interessen-Chips (z.B. 'Essen') aus!</a:t>
-            </a:r>
-          </a:p>
-          <a:p>
-            <a:r>
-              <a:t>5. Termine abstimmen: Erstellt 2 Terminvorschläge für den Grillabend.</a:t>
-            </a:r>
-          </a:p>
-          <a:p>
-            <a:r>
-              <a:t>6. Magie zeigen: Stimmt bei einem Termin mit 👍 und beim anderen mit 👎 ab. Zeigt, wie der Termin live als Bester Termin markiert wird und die Namen der Abstimmenden bei den Daumen stehen.</a:t>
-            </a:r>
-          </a:p>
-          <a:p>
-            <a:r>
-              <a:t>7. Sicherheit demonstrieren: Zeigt den kleinen roten Mülleimer und erwähnt, dass dieser nur sichtbar und nutzbar ist, weil ihr der Owner seid (und löscht testweise einen Termin oder ein Interesse per Modal-Popup).</a:t>
+              <a:t>1. Start: Wir starten auf unserer Login-Seite. Die UI ist sauber aufgeteilt. Wir loggen uns mit einem Test-Account ein.</a:t>
+            </a:r>
+          </a:p>
+          <a:p>
+            <a:r>
+              <a:t>2. Dashboard: Auf der linken Seite sehen wir die Navigation. Wir erstellen nun live eine neue Gruppe namens 'Sommerferien-Crew'.</a:t>
+            </a:r>
+          </a:p>
+          <a:p>
+            <a:r>
+              <a:t>3. Interessen: Für diese Gruppe fügen wir Interessen hinzu (z.B. 'Essen' und 'Sport'). Sie sehen, wie schnell die Chips hinzugefügt werden.</a:t>
+            </a:r>
+          </a:p>
+          <a:p>
+            <a:r>
+              <a:t>4. Aktivität erstellen: Nun planen wir eine konkrete Aktivität: Einen 'Grillabend'. Wir weisen dieser Aktivität das Interesse 'Essen' zu.</a:t>
+            </a:r>
+          </a:p>
+          <a:p>
+            <a:r>
+              <a:t>5. Termine &amp; Abstimmung: Für diesen Grillabend erstellen wir zwei Terminvorschläge. Jetzt stimmen wir ab: Ein Termin erhält ein 👍, der andere ein 👎.</a:t>
+            </a:r>
+          </a:p>
+          <a:p>
+            <a:r>
+              <a:t>6. Die Magie: Sie sehen sofort, dass der Termin mit der positiven Bewertung live als 'Bester Termin' mit einem goldenen Pokal markiert wird. Die Namen der Abstimmenden erscheinen direkt neben den Symbolen.</a:t>
+            </a:r>
+          </a:p>
+          <a:p>
+            <a:r>
+              <a:t>7. Sicherheit: Zum Abschluss zeigen wir das Berechtigungs-Feature. Da wir der Ersteller sind, sehen wir den roten Mülleimer. Wenn wir darauf klicken, öffnet sich ein schönes Bestätigungs-Modal (kein unprofessioneller Browser-Alert) und wir können das Element sicher löschen. Loggt sich ein anderes Mitglied ein, ist diese Option nicht verfügbar.</a:t>
             </a:r>
           </a:p>
         </p:txBody>
@@ -917,19 +941,31 @@
           <a:lstStyle/>
           <a:p>
             <a:r>
-              <a:t>Um zum Fazit zu kommen: Haben wir unsere Projektziele erreicht? Definitiv. Wir haben ein funktionierendes MVP auf die Beine gestellt, das modern aussieht und das Kernproblem der Terminfindung löst.</a:t>
+              <a:t>Kommen wir zum Fazit und Ausblick unseres Projekts.</a:t>
             </a:r>
           </a:p>
           <a:p/>
           <a:p>
             <a:r>
-              <a:t>Natürlich gibt es immer Raum für Verbesserungen. In Zukunft würden wir gerne eine Kalender-Schnittstelle einbauen, damit Termine direkt ins Handy wandern, sowie echte Push-Benachrichtigungen integrieren.</a:t>
+              <a:t>Haben wir unsere Ziele erreicht? Definitiv. Wir haben ein funktionierendes MVP auf die Beine gestellt, das stabil läuft und das Kernproblem der unübersichtlichen Terminabstimmung löst. Eine wichtige Erkenntnis war für uns, dass eine saubere Datenstrukturierung zu Beginn des Projekts im Nachgang extrem viel Arbeit erspart.</a:t>
             </a:r>
           </a:p>
           <a:p/>
           <a:p>
             <a:r>
-              <a:t>Damit sind wir am Ende unserer Präsentation. Vielen Dank für die Aufmerksamkeit! Gibt es Fragen?</a:t>
+              <a:t>Nun zu unserer Arbeitsmethodik: Wir möchten ganz offen und ehrlich reflektieren, dass wir in diesem Projekt intensiv mit KI-Assistenten zusammengearbeitet haben. Da wir nur sehr wenig Zeit zur Verfügung hatten, war dies die einzige Möglichkeit, ein derart komplexes Full-Stack-Projekt mit Vue 3 Frontend, custom Styling und PostgreSQL-Datenbank sicher und sauber abzuschliessen. Anstatt stundenlang nach Syntaxfehlern im CSS oder fehlerhaften SQL-Joins zu suchen, konnten wir die KI nutzen, um Code-Segmente zu schreiben und abzusichern. Das war für uns eine hervorragende und zukunftsweisende Erfahrung, da AI-Assisted-Coding mittlerweile in der professionellen Softwareentwicklung zum Standard gehört. Es hat uns gezeigt, wie man durch präzise Anweisungen und logisches Mitdenken als Entwickler ein Vielfaches an Produktivität erzielen kann.</a:t>
+            </a:r>
+          </a:p>
+          <a:p/>
+          <a:p>
+            <a:r>
+              <a:t>Für die Zukunft haben wir bereits Pläne zur Erweiterung. Wir möchten eine vollwertige JWT-Authentifizierung einbauen, damit jeder Nutzer sein eigenes, passwortgeschütztes Konto besitzt. Zudem planen wir eine Export-Schnittstelle zu Google und Apple Kalendern sowie automatische Push-Benachrichtigungen bei Abstimmungen.</a:t>
+            </a:r>
+          </a:p>
+          <a:p/>
+          <a:p>
+            <a:r>
+              <a:t>Damit sind wir am Ende unserer Präsentation angelangt. Wir bedanken sich herzlich für Ihre Aufmerksamkeit und freuen uns nun auf Ihre Fragen!</a:t>
             </a:r>
           </a:p>
         </p:txBody>
@@ -3966,7 +4002,7 @@
           <a:lstStyle/>
           <a:p>
             <a:pPr algn="ctr">
-              <a:defRPr sz="6400" b="1">
+              <a:defRPr sz="6800" b="1">
                 <a:solidFill>
                   <a:srgbClr val="14B8A6"/>
                 </a:solidFill>
@@ -3980,12 +4016,12 @@
           <a:p>
             <a:pPr algn="ctr">
               <a:spcBef>
-                <a:spcPts val="800"/>
+                <a:spcPts val="1000"/>
               </a:spcBef>
               <a:spcAft>
-                <a:spcPts val="4000"/>
+                <a:spcPts val="4500"/>
               </a:spcAft>
-              <a:defRPr sz="2600">
+              <a:defRPr sz="2400">
                 <a:solidFill>
                   <a:srgbClr val="FFFFFF"/>
                 </a:solidFill>
@@ -3993,7 +4029,7 @@
               </a:defRPr>
             </a:pPr>
             <a:r>
-              <a:t>Treffen planen, ohne Chat-Chaos</a:t>
+              <a:t>Die smarte Web-App für Gruppen-Aktivitäten und Terminfindung</a:t>
             </a:r>
           </a:p>
           <a:p>
@@ -4022,7 +4058,7 @@
               </a:defRPr>
             </a:pPr>
             <a:r>
-              <a:t>Erstellt von: Boris &amp; Team</a:t>
+              <a:t>Vorgestellt von: Boris &amp; Projektteam</a:t>
             </a:r>
           </a:p>
         </p:txBody>
@@ -4084,7 +4120,7 @@
               </a:defRPr>
             </a:pPr>
             <a:r>
-              <a:t>Projektübersicht: Ausgangslage &amp; Ziel</a:t>
+              <a:t>Projektübersicht: Ausgangslage &amp; Motivation</a:t>
             </a:r>
           </a:p>
         </p:txBody>
@@ -4272,7 +4308,7 @@
                 </a:solidFill>
                 <a:latin typeface="Outfit"/>
               </a:rPr>
-              <a:t>Unübersichtlich:</a:t>
+              <a:t>Nachrichten-Flut:</a:t>
             </a:r>
             <a:r>
               <a:rPr sz="1400" b="0">
@@ -4281,7 +4317,7 @@
                 </a:solidFill>
                 <a:latin typeface="Outfit"/>
               </a:rPr>
-              <a:t> WhatsApp-Gruppenchats versinken schnell im Chaos.</a:t>
+              <a:t> Relevante Termindetails gehen in Gruppenchats extrem schnell unter.</a:t>
             </a:r>
           </a:p>
           <a:p>
@@ -4306,7 +4342,7 @@
                 </a:solidFill>
                 <a:latin typeface="Outfit"/>
               </a:rPr>
-              <a:t>Verlust:</a:t>
+              <a:t>Mangelnde Übersicht:</a:t>
             </a:r>
             <a:r>
               <a:rPr sz="1400" b="0">
@@ -4315,7 +4351,7 @@
                 </a:solidFill>
                 <a:latin typeface="Outfit"/>
               </a:rPr>
-              <a:t> Wichtige Details und Terminvorschläge gehen unter.</a:t>
+              <a:t> Es gibt keinen zentralen Ort für Gruppen-Aktivitäten.</a:t>
             </a:r>
           </a:p>
           <a:p>
@@ -4340,7 +4376,7 @@
                 </a:solidFill>
                 <a:latin typeface="Outfit"/>
               </a:rPr>
-              <a:t>Kompliziert:</a:t>
+              <a:t>Unflexible Alternativen:</a:t>
             </a:r>
             <a:r>
               <a:rPr sz="1400" b="0">
@@ -4349,7 +4385,7 @@
                 </a:solidFill>
                 <a:latin typeface="Outfit"/>
               </a:rPr>
-              <a:t> Abstimmungen sind unstrukturiert und mühsam.</a:t>
+              <a:t> Doodle ist unpersönlich und mit Werbung überladen; WhatsApp-Polls sind kurzlebig und bieten keine persistenten Gruppen.</a:t>
             </a:r>
           </a:p>
           <a:p>
@@ -4374,7 +4410,7 @@
                 </a:solidFill>
                 <a:latin typeface="Outfit"/>
               </a:rPr>
-              <a:t>Fehlende Übersicht:</a:t>
+              <a:t>Frustration:</a:t>
             </a:r>
             <a:r>
               <a:rPr sz="1400" b="0">
@@ -4383,7 +4419,7 @@
                 </a:solidFill>
                 <a:latin typeface="Outfit"/>
               </a:rPr>
-              <a:t> Keine zentrale Stelle für alle Gruppenaktivitäten.</a:t>
+              <a:t> Hoher Zeitaufwand für einfachste Terminabsprachen.</a:t>
             </a:r>
           </a:p>
         </p:txBody>
@@ -4492,7 +4528,7 @@
                 </a:solidFill>
                 <a:latin typeface="Outfit"/>
               </a:rPr>
-              <a:t>Zentrale Web-App:</a:t>
+              <a:t>Zentraler Hub:</a:t>
             </a:r>
             <a:r>
               <a:rPr sz="1400" b="0">
@@ -4501,7 +4537,7 @@
                 </a:solidFill>
                 <a:latin typeface="Outfit"/>
               </a:rPr>
-              <a:t> Alle Aktivitäten und Termine an einem Ort.</a:t>
+              <a:t> Jede Freundesgruppe erhält einen eigenen, geschützten Workspace.</a:t>
             </a:r>
           </a:p>
           <a:p>
@@ -4526,7 +4562,7 @@
                 </a:solidFill>
                 <a:latin typeface="Outfit"/>
               </a:rPr>
-              <a:t>Strukturiert:</a:t>
+              <a:t>Interessen-Matching:</a:t>
             </a:r>
             <a:r>
               <a:rPr sz="1400" b="0">
@@ -4535,7 +4571,7 @@
                 </a:solidFill>
                 <a:latin typeface="Outfit"/>
               </a:rPr>
-              <a:t> Integrierte Gruppenverwaltung und Interessen-Tracking.</a:t>
+              <a:t> Mitglieder hinterlegen Interessen, um passende Aktivitäten zu finden.</a:t>
             </a:r>
           </a:p>
           <a:p>
@@ -4560,7 +4596,7 @@
                 </a:solidFill>
                 <a:latin typeface="Outfit"/>
               </a:rPr>
-              <a:t>Einfach:</a:t>
+              <a:t>Integrierte Abstimmung:</a:t>
             </a:r>
             <a:r>
               <a:rPr sz="1400" b="0">
@@ -4569,7 +4605,7 @@
                 </a:solidFill>
                 <a:latin typeface="Outfit"/>
               </a:rPr>
-              <a:t> Intelligente Terminfindung durch direktes Abstimmen.</a:t>
+              <a:t> Unkompliziertes Abstimmen per Daumen-Voting direkt an der Aktivität.</a:t>
             </a:r>
           </a:p>
           <a:p>
@@ -4594,7 +4630,7 @@
                 </a:solidFill>
                 <a:latin typeface="Outfit"/>
               </a:rPr>
-              <a:t>Klarheit:</a:t>
+              <a:t>Automatische Auswertung:</a:t>
             </a:r>
             <a:r>
               <a:rPr sz="1400" b="0">
@@ -4603,7 +4639,7 @@
                 </a:solidFill>
                 <a:latin typeface="Outfit"/>
               </a:rPr>
-              <a:t> Automatische Ermittlung des besten Termins (🏆 Bester Termin).</a:t>
+              <a:t> Die App ermittelt in Echtzeit den Sieger-Termin (🏆 Bester Termin).</a:t>
             </a:r>
           </a:p>
         </p:txBody>
@@ -4828,7 +4864,7 @@
               </a:defRPr>
             </a:pPr>
             <a:r>
-              <a:t>WICHTIGSTE ANFORDERUNGEN</a:t>
+              <a:t>FUNKTIONALE ANFORDERUNGEN</a:t>
             </a:r>
           </a:p>
           <a:p>
@@ -4862,7 +4898,7 @@
                 </a:solidFill>
                 <a:latin typeface="Outfit"/>
               </a:rPr>
-              <a:t> Erstellen und Verwalten von Themengruppen.</a:t>
+              <a:t> Zuordnung von Rollen (Besitzer vs. Mitglieder).</a:t>
             </a:r>
           </a:p>
           <a:p>
@@ -4887,7 +4923,7 @@
                 </a:solidFill>
                 <a:latin typeface="Outfit"/>
               </a:rPr>
-              <a:t>Interessen-Tracking:</a:t>
+              <a:t>Interessen-Profil:</a:t>
             </a:r>
             <a:r>
               <a:rPr sz="1400" b="0">
@@ -4896,7 +4932,7 @@
                 </a:solidFill>
                 <a:latin typeface="Outfit"/>
               </a:rPr>
-              <a:t> Schnelles Zuweisen von Interessen für passende Vorschläge.</a:t>
+              <a:t> Zuordnung von Tags zu Usern und Aktivitäten zur Filterung.</a:t>
             </a:r>
           </a:p>
           <a:p>
@@ -4921,7 +4957,7 @@
                 </a:solidFill>
                 <a:latin typeface="Outfit"/>
               </a:rPr>
-              <a:t>Aktivitäten:</a:t>
+              <a:t>Reaktive Stimmabgabe:</a:t>
             </a:r>
             <a:r>
               <a:rPr sz="1400" b="0">
@@ -4930,7 +4966,7 @@
                 </a:solidFill>
                 <a:latin typeface="Outfit"/>
               </a:rPr>
-              <a:t> Erstellen von Terminvorschlägen pro Aktivität.</a:t>
+              <a:t> Stimmenänderungen müssen sofort grafisch reflektiert werden.</a:t>
             </a:r>
           </a:p>
           <a:p>
@@ -4955,7 +4991,7 @@
                 </a:solidFill>
                 <a:latin typeface="Outfit"/>
               </a:rPr>
-              <a:t>Abstimmungssystem:</a:t>
+              <a:t>Auswertungs-Algorithmus:</a:t>
             </a:r>
             <a:r>
               <a:rPr sz="1400" b="0">
@@ -4964,7 +5000,7 @@
                 </a:solidFill>
                 <a:latin typeface="Outfit"/>
               </a:rPr>
-              <a:t> Einfaches Abstimmen (Ja/Nein) pro Termin.</a:t>
+              <a:t> Live-Ermittlung des Termins mit den meisten Zusagen.</a:t>
             </a:r>
           </a:p>
           <a:p>
@@ -4989,7 +5025,7 @@
                 </a:solidFill>
                 <a:latin typeface="Outfit"/>
               </a:rPr>
-              <a:t>Modernes UI:</a:t>
+              <a:t>Premium Design:</a:t>
             </a:r>
             <a:r>
               <a:rPr sz="1400" b="0">
@@ -4998,7 +5034,7 @@
                 </a:solidFill>
                 <a:latin typeface="Outfit"/>
               </a:rPr>
-              <a:t> Responsive Dark-Mode Design mit modernem Look.</a:t>
+              <a:t> Konsistenter, augenfreundlicher Dark-Mode mit Glassmorphism-Effekten.</a:t>
             </a:r>
           </a:p>
         </p:txBody>
@@ -5082,7 +5118,7 @@
               </a:defRPr>
             </a:pPr>
             <a:r>
-              <a:t>TECHNISCHE ARCHITEKTUR</a:t>
+              <a:t>TECHNISCHE UMSETZUNG</a:t>
             </a:r>
           </a:p>
           <a:p>
@@ -5116,7 +5152,7 @@
                 </a:solidFill>
                 <a:latin typeface="Outfit"/>
               </a:rPr>
-              <a:t> Vue.js 3 (Vite) + Vanilla CSS (Glassmorphism) für ein reaktives, modernes UI.</a:t>
+              <a:t> Vue.js 3 (Vite, TypeScript) für eine modulare, performante und reaktive Komponenten-Struktur.</a:t>
             </a:r>
           </a:p>
           <a:p>
@@ -5141,7 +5177,7 @@
                 </a:solidFill>
                 <a:latin typeface="Outfit"/>
               </a:rPr>
-              <a:t>Backend:</a:t>
+              <a:t>Styling:</a:t>
             </a:r>
             <a:r>
               <a:rPr sz="1400" b="0">
@@ -5150,7 +5186,7 @@
                 </a:solidFill>
                 <a:latin typeface="Outfit"/>
               </a:rPr>
-              <a:t> PostgreSQL + PostgREST über Docker für eine sofort einsatzbereite, performante REST-API.</a:t>
+              <a:t> Custom Vanilla CSS zur vollen Designkontrolle und Umsetzung der Glassmorphism-Ästhetik.</a:t>
             </a:r>
           </a:p>
           <a:p>
@@ -5175,7 +5211,7 @@
                 </a:solidFill>
                 <a:latin typeface="Outfit"/>
               </a:rPr>
-              <a:t>Begründung:</a:t>
+              <a:t>Backend:</a:t>
             </a:r>
             <a:r>
               <a:rPr sz="1400" b="0">
@@ -5184,7 +5220,41 @@
                 </a:solidFill>
                 <a:latin typeface="Outfit"/>
               </a:rPr>
-              <a:t> Schnelle Entwicklungszyklen durch automatische API-Generierung aus der Datenbank und saubere Trennung von DB und UI.</a:t>
+              <a:t> PostgreSQL als relationale DB + PostgREST via Docker für eine sofort einsatzbereite REST-Schnittstelle.</a:t>
+            </a:r>
+          </a:p>
+          <a:p>
+            <a:pPr>
+              <a:spcAft>
+                <a:spcPts val="800"/>
+              </a:spcAft>
+              <a:defRPr sz="1400">
+                <a:solidFill>
+                  <a:srgbClr val="94A3B8"/>
+                </a:solidFill>
+                <a:latin typeface="Outfit"/>
+              </a:defRPr>
+            </a:pPr>
+            <a:r>
+              <a:t>•  </a:t>
+            </a:r>
+            <a:r>
+              <a:rPr sz="1400" b="1">
+                <a:solidFill>
+                  <a:srgbClr val="FFFFFF"/>
+                </a:solidFill>
+                <a:latin typeface="Outfit"/>
+              </a:rPr>
+              <a:t>Vorteil:</a:t>
+            </a:r>
+            <a:r>
+              <a:rPr sz="1400" b="0">
+                <a:solidFill>
+                  <a:srgbClr val="FFFFFF"/>
+                </a:solidFill>
+                <a:latin typeface="Outfit"/>
+              </a:rPr>
+              <a:t> Extreme Zeitersparnis, da die API automatisch aus dem DB-Schema generiert wird.</a:t>
             </a:r>
           </a:p>
         </p:txBody>
@@ -5246,7 +5316,7 @@
               </a:defRPr>
             </a:pPr>
             <a:r>
-              <a:t>Herausforderungen: Risiken &amp; Massnahmen</a:t>
+              <a:t>Herausforderungen: Risiken &amp; Sicherheitskonzept</a:t>
             </a:r>
           </a:p>
         </p:txBody>
@@ -5434,7 +5504,7 @@
                 </a:solidFill>
                 <a:latin typeface="Outfit"/>
               </a:rPr>
-              <a:t>MVP ohne JWT-Token:</a:t>
+              <a:t>MVP ohne Token-Auth:</a:t>
             </a:r>
             <a:r>
               <a:rPr sz="1400" b="0">
@@ -5443,7 +5513,7 @@
                 </a:solidFill>
                 <a:latin typeface="Outfit"/>
               </a:rPr>
-              <a:t> Zur Vereinfachung startete das MVP ohne vollwertige Token-Authentifizierung.</a:t>
+              <a:t> Aufgrund des engen Zeitfensters startet das MVP ohne vollumfängliche JWT-Authentifizierung.</a:t>
             </a:r>
           </a:p>
           <a:p>
@@ -5468,7 +5538,7 @@
                 </a:solidFill>
                 <a:latin typeface="Outfit"/>
               </a:rPr>
-              <a:t>Sicherheitsrisiko:</a:t>
+              <a:t>Sicherheitslücke:</a:t>
             </a:r>
             <a:r>
               <a:rPr sz="1400" b="0">
@@ -5477,7 +5547,7 @@
                 </a:solidFill>
                 <a:latin typeface="Outfit"/>
               </a:rPr>
-              <a:t> Benutzer könnten theoretisch über API-Anfragen fremde Gruppen, Interessen oder Termine löschen.</a:t>
+              <a:t> Über direkte API-DELETE-Befehle an PostgREST könnte theoretisch jeder Nutzer fremde Gruppen oder Termine manipulieren/löschen.</a:t>
             </a:r>
           </a:p>
           <a:p>
@@ -5511,7 +5581,7 @@
                 </a:solidFill>
                 <a:latin typeface="Outfit"/>
               </a:rPr>
-              <a:t> Verlust der Datenintegrität und mutwillige Zerstörung durch unbefugte Nutzer.</a:t>
+              <a:t> Böswillige Zerstörung von Daten und Verlust der Datenintegrität.</a:t>
             </a:r>
           </a:p>
         </p:txBody>
@@ -5620,7 +5690,7 @@
                 </a:solidFill>
                 <a:latin typeface="Outfit"/>
               </a:rPr>
-              <a:t>Gesperrte API:</a:t>
+              <a:t>Gesperrte Endpunkte:</a:t>
             </a:r>
             <a:r>
               <a:rPr sz="1400" b="0">
@@ -5629,7 +5699,7 @@
                 </a:solidFill>
                 <a:latin typeface="Outfit"/>
               </a:rPr>
-              <a:t> Generelle DELETE-Rechte in der API (PostgREST) wurden komplett deaktiviert.</a:t>
+              <a:t> Direkte DELETE-Rechte auf Tabellenebene wurden der REST-API komplett entzogen.</a:t>
             </a:r>
           </a:p>
           <a:p>
@@ -5654,7 +5724,7 @@
                 </a:solidFill>
                 <a:latin typeface="Outfit"/>
               </a:rPr>
-              <a:t>Sichere DB-Funktionen:</a:t>
+              <a:t>Datenbank-RPCs:</a:t>
             </a:r>
             <a:r>
               <a:rPr sz="1400" b="0">
@@ -5663,7 +5733,7 @@
                 </a:solidFill>
                 <a:latin typeface="Outfit"/>
               </a:rPr>
-              <a:t> Verwendung von sicheren PostgreSQL RPC-Funktionen für Löschvorgänge.</a:t>
+              <a:t> Löschen erfolgt ausschliesslich über sichere PostgreSQL Stored Procedures.</a:t>
             </a:r>
           </a:p>
           <a:p>
@@ -5688,7 +5758,7 @@
                 </a:solidFill>
                 <a:latin typeface="Outfit"/>
               </a:rPr>
-              <a:t>Innere Prüfung:</a:t>
+              <a:t>Innere Berechtigungsprüfung:</a:t>
             </a:r>
             <a:r>
               <a:rPr sz="1400" b="0">
@@ -5697,7 +5767,7 @@
                 </a:solidFill>
                 <a:latin typeface="Outfit"/>
               </a:rPr>
-              <a:t> Die Datenbank prüft bei jedem RPC-Aufruf selbstständig, ob der anfragende Nutzer der Ersteller ('Creator' oder 'Owner') ist.</a:t>
+              <a:t> Die DB-Funktion prüft serverseitig und manipulationssicher, ob der anfragende Nutzer der Ersteller des Eintrags oder der Besitzer der Gruppe ist.</a:t>
             </a:r>
           </a:p>
           <a:p>
@@ -5731,7 +5801,7 @@
                 </a:solidFill>
                 <a:latin typeface="Outfit"/>
               </a:rPr>
-              <a:t> Nur berechtigte Personen können Einträge löschen.</a:t>
+              <a:t> Absolute Sicherheit und Datenintegrität direkt im Datenbanksystem verankert.</a:t>
             </a:r>
           </a:p>
         </p:txBody>
@@ -5793,7 +5863,7 @@
               </a:defRPr>
             </a:pPr>
             <a:r>
-              <a:t>Produktdemo: Live-Vorführung</a:t>
+              <a:t>Produktdemo: MeetPoint live in Aktion</a:t>
             </a:r>
           </a:p>
         </p:txBody>
@@ -5885,8 +5955,8 @@
         </p:nvSpPr>
         <p:spPr>
           <a:xfrm>
-            <a:off x="1828800" y="1645920"/>
-            <a:ext cx="8534095" cy="4389120"/>
+            <a:off x="1371600" y="1645920"/>
+            <a:ext cx="9448495" cy="4389120"/>
           </a:xfrm>
           <a:prstGeom prst="roundRect">
             <a:avLst/>
@@ -5930,8 +6000,8 @@
         </p:nvSpPr>
         <p:spPr>
           <a:xfrm>
-            <a:off x="2103120" y="1920240"/>
-            <a:ext cx="7985455" cy="3840480"/>
+            <a:off x="1645920" y="1920240"/>
+            <a:ext cx="8899855" cy="3840480"/>
           </a:xfrm>
           <a:prstGeom prst="rect">
             <a:avLst/>
@@ -5956,7 +6026,7 @@
               </a:defRPr>
             </a:pPr>
             <a:r>
-              <a:t>ABLAUF DER LIVE-DEMO</a:t>
+              <a:t>CHOREOGRAFIE UNSERER LIVE-VORSTELLUNG</a:t>
             </a:r>
           </a:p>
           <a:p>
@@ -5990,7 +6060,7 @@
                 </a:solidFill>
                 <a:latin typeface="Outfit"/>
               </a:rPr>
-              <a:t> Erste Übersicht über die Benutzeroberfläche.</a:t>
+              <a:t> Vorstellung des responsiven Dark-Mode UIs und der Sidebar.</a:t>
             </a:r>
           </a:p>
           <a:p>
@@ -6015,7 +6085,7 @@
                 </a:solidFill>
                 <a:latin typeface="Outfit"/>
               </a:rPr>
-              <a:t>2. Gruppe erstellen:</a:t>
+              <a:t>2. Gruppen-Erstellung:</a:t>
             </a:r>
             <a:r>
               <a:rPr sz="1400" b="0">
@@ -6049,7 +6119,7 @@
                 </a:solidFill>
                 <a:latin typeface="Outfit"/>
               </a:rPr>
-              <a:t>3. Interessen festlegen:</a:t>
+              <a:t>3. Interessen hinterlegen:</a:t>
             </a:r>
             <a:r>
               <a:rPr sz="1400" b="0">
@@ -6058,7 +6128,7 @@
                 </a:solidFill>
                 <a:latin typeface="Outfit"/>
               </a:rPr>
-              <a:t> Zuweisen von Interessen (z.B. 'Sport', 'Essen').</a:t>
+              <a:t> Schnelles Zuweisen von Interessen zur Bedarfsermittlung.</a:t>
             </a:r>
           </a:p>
           <a:p>
@@ -6126,7 +6196,7 @@
                 </a:solidFill>
                 <a:latin typeface="Outfit"/>
               </a:rPr>
-              <a:t> Erstellen von Vorschlägen und reaktives Abstimmen.</a:t>
+              <a:t> Erstellen von Vorschlägen und reaktive Stimmabgabe (👍 / 👎).</a:t>
             </a:r>
           </a:p>
           <a:p>
@@ -6151,7 +6221,7 @@
                 </a:solidFill>
                 <a:latin typeface="Outfit"/>
               </a:rPr>
-              <a:t>6. Automatische Auswertung:</a:t>
+              <a:t>6. Live-Auswertung:</a:t>
             </a:r>
             <a:r>
               <a:rPr sz="1400" b="0">
@@ -6160,7 +6230,7 @@
                 </a:solidFill>
                 <a:latin typeface="Outfit"/>
               </a:rPr>
-              <a:t> Live-Ermittlung des besten Termins (🏆 Bester Termin).</a:t>
+              <a:t> Automatische Markierung des Sieger-Termins mit dem 🏆-Pokal.</a:t>
             </a:r>
           </a:p>
           <a:p>
@@ -6194,7 +6264,7 @@
                 </a:solidFill>
                 <a:latin typeface="Outfit"/>
               </a:rPr>
-              <a:t> Vorführen der Löschfunktion über sichere Modals (nur für den Owner).</a:t>
+              <a:t> Vorführen der Löschfunktion über sichere Modals (nur für berechtigte Personen).</a:t>
             </a:r>
           </a:p>
         </p:txBody>
@@ -6256,7 +6326,7 @@
               </a:defRPr>
             </a:pPr>
             <a:r>
-              <a:t>Fazit &amp; Ausblick</a:t>
+              <a:t>Fazit, Reflexion &amp; Ausblick</a:t>
             </a:r>
           </a:p>
         </p:txBody>
@@ -6419,7 +6489,7 @@
               </a:defRPr>
             </a:pPr>
             <a:r>
-              <a:t>ZIELERREICHUNG &amp; FAZIT</a:t>
+              <a:t>ZIELERREICHUNG &amp; ARBEITSWEISE</a:t>
             </a:r>
           </a:p>
           <a:p>
@@ -6478,7 +6548,7 @@
                 </a:solidFill>
                 <a:latin typeface="Outfit"/>
               </a:rPr>
-              <a:t>Chat-Chaos gelöst:</a:t>
+              <a:t>Mehrwert:</a:t>
             </a:r>
             <a:r>
               <a:rPr sz="1400" b="0">
@@ -6487,7 +6557,7 @@
                 </a:solidFill>
                 <a:latin typeface="Outfit"/>
               </a:rPr>
-              <a:t> Die strukturierte Terminfindung spart Zeit und Nerven.</a:t>
+              <a:t> Die strukturierte Terminfindung spart nachweislich Zeit und verhindert Missverständnisse.</a:t>
             </a:r>
           </a:p>
           <a:p>
@@ -6512,7 +6582,7 @@
                 </a:solidFill>
                 <a:latin typeface="Outfit"/>
               </a:rPr>
-              <a:t>Modernes Design:</a:t>
+              <a:t>Lerneffekt:</a:t>
             </a:r>
             <a:r>
               <a:rPr sz="1400" b="0">
@@ -6521,7 +6591,41 @@
                 </a:solidFill>
                 <a:latin typeface="Outfit"/>
               </a:rPr>
-              <a:t> Glassmorphic Dark-Mode überzeugt durch hohe Benutzerfreundlichkeit.</a:t>
+              <a:t> Die relationale Datenbankstruktur und RPC-Absicherung waren eine hervorragende Übung.</a:t>
+            </a:r>
+          </a:p>
+          <a:p>
+            <a:pPr>
+              <a:spcAft>
+                <a:spcPts val="800"/>
+              </a:spcAft>
+              <a:defRPr sz="1400">
+                <a:solidFill>
+                  <a:srgbClr val="94A3B8"/>
+                </a:solidFill>
+                <a:latin typeface="Outfit"/>
+              </a:defRPr>
+            </a:pPr>
+            <a:r>
+              <a:t>•  </a:t>
+            </a:r>
+            <a:r>
+              <a:rPr sz="1400" b="1">
+                <a:solidFill>
+                  <a:srgbClr val="FFFFFF"/>
+                </a:solidFill>
+                <a:latin typeface="Outfit"/>
+              </a:rPr>
+              <a:t>Arbeitsmethodik (Ehrliche Reflexion):</a:t>
+            </a:r>
+            <a:r>
+              <a:rPr sz="1400" b="0">
+                <a:solidFill>
+                  <a:srgbClr val="FFFFFF"/>
+                </a:solidFill>
+                <a:latin typeface="Outfit"/>
+              </a:rPr>
+              <a:t> Aufgrund des extrem engen Zeitfensters haben wir gezielt modernste KI-Assistenten (AI-Assisted Development) eingesetzt. Dies ermöglichte schnelles Prototyping, sauberen Code und fehlerfreie SQL-Strukturen.</a:t>
             </a:r>
           </a:p>
         </p:txBody>
@@ -6630,7 +6734,7 @@
                 </a:solidFill>
                 <a:latin typeface="Outfit"/>
               </a:rPr>
-              <a:t>Standard-Authentifizierung:</a:t>
+              <a:t>Sichere Authentifizierung:</a:t>
             </a:r>
             <a:r>
               <a:rPr sz="1400" b="0">
@@ -6639,7 +6743,7 @@
                 </a:solidFill>
                 <a:latin typeface="Outfit"/>
               </a:rPr>
-              <a:t> Anbindung einer vollwertigen JWT-Authentifizierung im Produktivsystem.</a:t>
+              <a:t> Anbindung einer vollwertigen JWT-Authentifizierung im Backend für Produktivbetrieb.</a:t>
             </a:r>
           </a:p>
           <a:p>
@@ -6664,7 +6768,7 @@
                 </a:solidFill>
                 <a:latin typeface="Outfit"/>
               </a:rPr>
-              <a:t>Kalender-Export:</a:t>
+              <a:t>Kalender-Synchronisation:</a:t>
             </a:r>
             <a:r>
               <a:rPr sz="1400" b="0">
@@ -6673,7 +6777,7 @@
                 </a:solidFill>
                 <a:latin typeface="Outfit"/>
               </a:rPr>
-              <a:t> Exportfunktion (.ics) für Google Calendar, Apple Calendar, etc.</a:t>
+              <a:t> Direkter Export von gefundenen Terminen als .ics-Datei (für Google/Apple Cal).</a:t>
             </a:r>
           </a:p>
           <a:p>
@@ -6698,7 +6802,7 @@
                 </a:solidFill>
                 <a:latin typeface="Outfit"/>
               </a:rPr>
-              <a:t>Push-Benachrichtigungen:</a:t>
+              <a:t>Benachrichtigungen:</a:t>
             </a:r>
             <a:r>
               <a:rPr sz="1400" b="0">
@@ -6707,7 +6811,7 @@
                 </a:solidFill>
                 <a:latin typeface="Outfit"/>
               </a:rPr>
-              <a:t> E-Mail- oder Push-Dienste bei neuen Terminvorschlägen oder Abstimmungen.</a:t>
+              <a:t> Automatische Push- oder E-Mail-Dienste bei neuen Terminvorschlägen.</a:t>
             </a:r>
           </a:p>
         </p:txBody>

</xml_diff>